<commit_message>
docs: add the 8-slide Presto pitch deck
</commit_message>
<xml_diff>
--- a/docs/presentacion-presto.pptx
+++ b/docs/presentacion-presto.pptx
@@ -4430,45 +4430,6 @@
         </p:nvSpPr>
         <p:spPr>
           <a:xfrm>
-            <a:off x="1874519" y="932688"/>
-            <a:ext cx="7315200" cy="868680"/>
-          </a:xfrm>
-          <a:prstGeom prst="rect">
-            <a:avLst/>
-          </a:prstGeom>
-          <a:noFill/>
-        </p:spPr>
-        <p:txBody>
-          <a:bodyPr wrap="square" anchor="t" lIns="0" rIns="0" tIns="0" bIns="0">
-            <a:spAutoFit/>
-          </a:bodyPr>
-          <a:lstStyle/>
-          <a:p>
-            <a:pPr algn="l">
-              <a:lnSpc>
-                <a:spcPct val="100000"/>
-              </a:lnSpc>
-            </a:pPr>
-            <a:r>
-              <a:rPr sz="5800" b="1">
-                <a:solidFill>
-                  <a:srgbClr val="FFFFFF"/>
-                </a:solidFill>
-                <a:latin typeface="Segoe UI"/>
-              </a:rPr>
-              <a:t>Presto</a:t>
-            </a:r>
-          </a:p>
-        </p:txBody>
-      </p:sp>
-      <p:sp>
-        <p:nvSpPr>
-          <p:cNvPr id="4" name="TextBox 3"/>
-          <p:cNvSpPr txBox="1"/>
-          <p:nvPr/>
-        </p:nvSpPr>
-        <p:spPr>
-          <a:xfrm>
             <a:off x="1920240" y="1828800"/>
             <a:ext cx="8778240" cy="731520"/>
           </a:xfrm>
@@ -4496,6 +4457,50 @@
                 <a:latin typeface="Segoe UI"/>
               </a:rPr>
               <a:t>Finanzas e inversiones entre personas, en pesos y dólares.</a:t>
+            </a:r>
+          </a:p>
+        </p:txBody>
+      </p:sp>
+      <p:sp>
+        <p:nvSpPr>
+          <p:cNvPr id="4" name="TextBox 3"/>
+          <p:cNvSpPr txBox="1"/>
+          <p:nvPr/>
+        </p:nvSpPr>
+        <p:spPr>
+          <a:xfrm>
+            <a:off x="1874519" y="932688"/>
+            <a:ext cx="7772400" cy="960120"/>
+          </a:xfrm>
+          <a:prstGeom prst="rect">
+            <a:avLst/>
+          </a:prstGeom>
+          <a:noFill/>
+        </p:spPr>
+        <p:txBody>
+          <a:bodyPr wrap="square" lIns="0" rIns="0" tIns="0" bIns="0">
+            <a:spAutoFit/>
+          </a:bodyPr>
+          <a:lstStyle/>
+          <a:p>
+            <a:pPr algn="l"/>
+            <a:r>
+              <a:rPr sz="5800" b="1">
+                <a:solidFill>
+                  <a:srgbClr val="FFFFFF"/>
+                </a:solidFill>
+                <a:latin typeface="Segoe UI"/>
+              </a:rPr>
+              <a:t>Presto</a:t>
+            </a:r>
+            <a:r>
+              <a:rPr sz="5800" b="1">
+                <a:solidFill>
+                  <a:srgbClr val="93C5FD"/>
+                </a:solidFill>
+                <a:latin typeface="Segoe UI"/>
+              </a:rPr>
+              <a:t>.</a:t>
             </a:r>
           </a:p>
         </p:txBody>
@@ -6802,7 +6807,7 @@
         <p:spPr>
           <a:xfrm>
             <a:off x="777240" y="1097280"/>
-            <a:ext cx="10789920" cy="822960"/>
+            <a:ext cx="7772400" cy="960120"/>
           </a:xfrm>
           <a:prstGeom prst="rect">
             <a:avLst/>
@@ -6810,16 +6815,12 @@
           <a:noFill/>
         </p:spPr>
         <p:txBody>
-          <a:bodyPr wrap="square" anchor="t" lIns="0" rIns="0" tIns="0" bIns="0">
+          <a:bodyPr wrap="square" lIns="0" rIns="0" tIns="0" bIns="0">
             <a:spAutoFit/>
           </a:bodyPr>
           <a:lstStyle/>
           <a:p>
-            <a:pPr algn="l">
-              <a:lnSpc>
-                <a:spcPct val="100000"/>
-              </a:lnSpc>
-            </a:pPr>
+            <a:pPr algn="l"/>
             <a:r>
               <a:rPr sz="5600" b="1">
                 <a:solidFill>
@@ -6828,6 +6829,15 @@
                 <a:latin typeface="Segoe UI"/>
               </a:rPr>
               <a:t>Presto</a:t>
+            </a:r>
+            <a:r>
+              <a:rPr sz="5600" b="1">
+                <a:solidFill>
+                  <a:srgbClr val="93C5FD"/>
+                </a:solidFill>
+                <a:latin typeface="Segoe UI"/>
+              </a:rPr>
+              <a:t>.</a:t>
             </a:r>
           </a:p>
         </p:txBody>

</xml_diff>